<commit_message>
Day 2 M5: remove 'Versioning workflow' slide
Dropped the entire 'Versioning workflow' body block from Module 5.
The four-step promote-to-default flow is a valid pattern but doesn't
earn its place in the module — the important governance beats are
already covered on slide 15 (Governance you get from toolbox), and
the practical demo (slide 6) shows the consumer pattern that matters
for attendees. Versioning as a standalone slide read as filler.

Removed from both day2.js and slides/day2/module-5-foundry-toolbox.md
so the markdown source stays in lockstep with the built deck.

Slide count: 19 -> 18. Downstream slide numbers shifted by one
(old slide 17 'When to build a function tool instead' is now
slide 16; 'Common traps' is slide 17; 'Takeaways' is slide 18).

Co-authored-by: Copilot <223556219+Copilot@users.noreply.github.com>
</commit_message>
<xml_diff>
--- a/decks/day2/module-5-foundry-toolbox.pptx
+++ b/decks/day2/module-5-foundry-toolbox.pptx
@@ -23,10 +23,9 @@
     <p:sldId id="271" r:id="rId17"/>
     <p:sldId id="272" r:id="rId18"/>
     <p:sldId id="273" r:id="rId19"/>
-    <p:sldId id="274" r:id="rId20"/>
   </p:sldIdLst>
   <p:notesMasterIdLst>
-    <p:notesMasterId r:id="rId21"/>
+    <p:notesMasterId r:id="rId20"/>
   </p:notesMasterIdLst>
   <p:sldSz cx="9144000" cy="5143500"/>
   <p:notesSz cx="5143500" cy="9144000"/>
@@ -1159,10 +1158,10 @@
           <a:p>
             <a:r>
               <a:rPr lang="en-US" dirty="0"/>
-              <a:t>• Four-step workflow — attendees will run this in production
-• Test at developer endpoint, promote to default
-• No agent redeploy — the consumer endpoint always serves default
-• Same publish discipline as Prompt agents (Day 1 Module 6)</a:t>
+              <a:t>• Decision framework — left vs. right
+• Function tools = flexibility, quick prototyping
+• Toolbox = shared, governed, enterprise-integrated
+• The bottom line = mix. Sets up Module 6 next.</a:t>
             </a:r>
             <a:endParaRPr lang="en-US" dirty="0"/>
           </a:p>
@@ -1250,10 +1249,11 @@
           <a:p>
             <a:r>
               <a:rPr lang="en-US" dirty="0"/>
-              <a:t>• Decision framework — left vs. right
-• Function tools = flexibility, quick prototyping
-• Toolbox = shared, governed, enterprise-integrated
-• The bottom line = mix. Sets up Module 6 next.</a:t>
+              <a:t>• Six traps — same pattern as prior modules
+• The credentials-in-YAML trap is the biggest — attendees WILL try to shortcut
+• Endpoint confusion catches everyone once
+• 'Cost' bullet is real — Bing has per-call pricing
+• RAI policy is the governance win most attendees skip</a:t>
             </a:r>
             <a:endParaRPr lang="en-US" dirty="0"/>
           </a:p>
@@ -1341,11 +1341,9 @@
           <a:p>
             <a:r>
               <a:rPr lang="en-US" dirty="0"/>
-              <a:t>• Six traps — same pattern as prior modules
-• The credentials-in-YAML trap is the biggest — attendees WILL try to shortcut
-• Endpoint confusion catches everyone once
-• 'Cost' bullet is real — Bing has per-call pricing
-• RAI policy is the governance win most attendees skip</a:t>
+              <a:t>• Six-bullet recap
+• Bridge to Module 6 — the hands-on tool authoring
+• Time check — Modules 1+2+3+4+5 = ~160 min in against 240 budget</a:t>
             </a:r>
             <a:endParaRPr lang="en-US" dirty="0"/>
           </a:p>
@@ -1369,96 +1367,6 @@
             <a:fld id="{F7021451-1387-4CA6-816F-3879F97B5CBC}" type="slidenum">
               <a:rPr lang="en-US"/>
               <a:t>18</a:t>
-            </a:fld>
-            <a:endParaRPr lang="en-US"/>
-          </a:p>
-        </p:txBody>
-      </p:sp>
-    </p:spTree>
-    <p:extLst>
-      <p:ext uri="{BB962C8B-B14F-4D97-AF65-F5344CB8AC3E}">
-        <p14:creationId xmlns:p14="http://schemas.microsoft.com/office/powerpoint/2010/main" val="1024086991"/>
-      </p:ext>
-    </p:extLst>
-  </p:cSld>
-  <p:clrMapOvr>
-    <a:masterClrMapping/>
-  </p:clrMapOvr>
-</p:notes>
-</file>
-
-<file path=ppt/notesSlides/notesSlide19.xml><?xml version="1.0" encoding="utf-8"?>
-<p:notes xmlns:a="http://schemas.openxmlformats.org/drawingml/2006/main" xmlns:r="http://schemas.openxmlformats.org/officeDocument/2006/relationships" xmlns:p="http://schemas.openxmlformats.org/presentationml/2006/main">
-  <p:cSld>
-    <p:spTree>
-      <p:nvGrpSpPr>
-        <p:cNvPr id="1" name=""/>
-        <p:cNvGrpSpPr/>
-        <p:nvPr/>
-      </p:nvGrpSpPr>
-      <p:grpSpPr>
-        <a:xfrm>
-          <a:off x="0" y="0"/>
-          <a:ext cx="0" cy="0"/>
-          <a:chOff x="0" y="0"/>
-          <a:chExt cx="0" cy="0"/>
-        </a:xfrm>
-      </p:grpSpPr>
-      <p:sp>
-        <p:nvSpPr>
-          <p:cNvPr id="2" name="Slide Image Placeholder 1"/>
-          <p:cNvSpPr>
-            <a:spLocks noGrp="1" noRot="1" noChangeAspect="1"/>
-          </p:cNvSpPr>
-          <p:nvPr>
-            <p:ph type="sldImg"/>
-          </p:nvPr>
-        </p:nvSpPr>
-        <p:spPr/>
-      </p:sp>
-      <p:sp>
-        <p:nvSpPr>
-          <p:cNvPr id="3" name="Notes Placeholder 2"/>
-          <p:cNvSpPr>
-            <a:spLocks noGrp="1"/>
-          </p:cNvSpPr>
-          <p:nvPr>
-            <p:ph type="body" idx="1"/>
-          </p:nvPr>
-        </p:nvSpPr>
-        <p:spPr/>
-        <p:txBody>
-          <a:bodyPr/>
-          <a:lstStyle/>
-          <a:p>
-            <a:r>
-              <a:rPr lang="en-US" dirty="0"/>
-              <a:t>• Six-bullet recap
-• Bridge to Module 6 — the hands-on tool authoring
-• Time check — Modules 1+2+3+4+5 = ~160 min in against 240 budget</a:t>
-            </a:r>
-            <a:endParaRPr lang="en-US" dirty="0"/>
-          </a:p>
-        </p:txBody>
-      </p:sp>
-      <p:sp>
-        <p:nvSpPr>
-          <p:cNvPr id="4" name="Slide Number Placeholder 3"/>
-          <p:cNvSpPr>
-            <a:spLocks noGrp="1"/>
-          </p:cNvSpPr>
-          <p:nvPr>
-            <p:ph type="sldNum" sz="quarter" idx="10"/>
-          </p:nvPr>
-        </p:nvSpPr>
-        <p:spPr/>
-        <p:txBody>
-          <a:bodyPr/>
-          <a:lstStyle/>
-          <a:p>
-            <a:fld id="{F7021451-1387-4CA6-816F-3879F97B5CBC}" type="slidenum">
-              <a:rPr lang="en-US"/>
-              <a:t>19</a:t>
             </a:fld>
             <a:endParaRPr lang="en-US"/>
           </a:p>
@@ -5760,7 +5668,7 @@
                 <a:ea typeface="Calibri" pitchFamily="34" charset="-122"/>
                 <a:cs typeface="Calibri" pitchFamily="34" charset="-120"/>
               </a:rPr>
-              <a:t>Versioning workflow</a:t>
+              <a:t>When to build a function tool instead</a:t>
             </a:r>
             <a:endParaRPr lang="en-US" sz="2800" dirty="0"/>
           </a:p>
@@ -5775,6 +5683,296 @@
         <p:spPr>
           <a:xfrm>
             <a:off x="365760" y="1097280"/>
+            <a:ext cx="4069080" cy="365760"/>
+          </a:xfrm>
+          <a:prstGeom prst="rect">
+            <a:avLst/>
+          </a:prstGeom>
+          <a:noFill/>
+          <a:ln/>
+        </p:spPr>
+        <p:txBody>
+          <a:bodyPr wrap="square" lIns="0" tIns="0" rIns="0" bIns="0" rtlCol="0" anchor="ctr"/>
+          <a:lstStyle/>
+          <a:p>
+            <a:pPr indent="0" marL="0">
+              <a:buNone/>
+            </a:pPr>
+            <a:r>
+              <a:rPr lang="en-US" sz="2000" b="1" dirty="0">
+                <a:solidFill>
+                  <a:srgbClr val="1E2761"/>
+                </a:solidFill>
+                <a:latin typeface="Calibri" pitchFamily="34" charset="0"/>
+                <a:ea typeface="Calibri" pitchFamily="34" charset="-122"/>
+                <a:cs typeface="Calibri" pitchFamily="34" charset="-120"/>
+              </a:rPr>
+              <a:t>Custom function tool (Module 6)</a:t>
+            </a:r>
+            <a:endParaRPr lang="en-US" sz="2000" dirty="0"/>
+          </a:p>
+        </p:txBody>
+      </p:sp>
+      <p:sp>
+        <p:nvSpPr>
+          <p:cNvPr id="6" name="Text 4"/>
+          <p:cNvSpPr/>
+          <p:nvPr/>
+        </p:nvSpPr>
+        <p:spPr>
+          <a:xfrm>
+            <a:off x="4709160" y="1097280"/>
+            <a:ext cx="4069080" cy="365760"/>
+          </a:xfrm>
+          <a:prstGeom prst="rect">
+            <a:avLst/>
+          </a:prstGeom>
+          <a:noFill/>
+          <a:ln/>
+        </p:spPr>
+        <p:txBody>
+          <a:bodyPr wrap="square" lIns="0" tIns="0" rIns="0" bIns="0" rtlCol="0" anchor="ctr"/>
+          <a:lstStyle/>
+          <a:p>
+            <a:pPr indent="0" marL="0">
+              <a:buNone/>
+            </a:pPr>
+            <a:r>
+              <a:rPr lang="en-US" sz="2000" b="1" dirty="0">
+                <a:solidFill>
+                  <a:srgbClr val="1E2761"/>
+                </a:solidFill>
+                <a:latin typeface="Calibri" pitchFamily="34" charset="0"/>
+                <a:ea typeface="Calibri" pitchFamily="34" charset="-122"/>
+                <a:cs typeface="Calibri" pitchFamily="34" charset="-120"/>
+              </a:rPr>
+              <a:t>Foundry Toolbox</a:t>
+            </a:r>
+            <a:endParaRPr lang="en-US" sz="2000" dirty="0"/>
+          </a:p>
+        </p:txBody>
+      </p:sp>
+      <p:sp>
+        <p:nvSpPr>
+          <p:cNvPr id="7" name="Text 5"/>
+          <p:cNvSpPr/>
+          <p:nvPr/>
+        </p:nvSpPr>
+        <p:spPr>
+          <a:xfrm>
+            <a:off x="365760" y="1554480"/>
+            <a:ext cx="4069080" cy="3291840"/>
+          </a:xfrm>
+          <a:prstGeom prst="rect">
+            <a:avLst/>
+          </a:prstGeom>
+          <a:noFill/>
+          <a:ln/>
+        </p:spPr>
+        <p:txBody>
+          <a:bodyPr wrap="square" rtlCol="0" anchor="ctr"/>
+          <a:lstStyle/>
+          <a:p>
+            <a:pPr marL="342900" indent="-342900">
+              <a:spcAft>
+                <a:spcPts val="600"/>
+              </a:spcAft>
+              <a:buSzPct val="100000"/>
+              <a:buChar char="•"/>
+            </a:pPr>
+            <a:r>
+              <a:rPr lang="en-US" sz="1500" dirty="0">
+                <a:solidFill>
+                  <a:srgbClr val="212121"/>
+                </a:solidFill>
+                <a:latin typeface="Calibri" pitchFamily="34" charset="0"/>
+                <a:ea typeface="Calibri" pitchFamily="34" charset="-122"/>
+                <a:cs typeface="Calibri" pitchFamily="34" charset="-120"/>
+              </a:rPr>
+              <a:t>Logic doesn't fit any Toolbox catalog entry</a:t>
+            </a:r>
+            <a:endParaRPr lang="en-US" sz="1500" dirty="0"/>
+          </a:p>
+          <a:p>
+            <a:pPr marL="342900" indent="-342900">
+              <a:spcAft>
+                <a:spcPts val="600"/>
+              </a:spcAft>
+              <a:buSzPct val="100000"/>
+              <a:buChar char="•"/>
+            </a:pPr>
+            <a:r>
+              <a:rPr lang="en-US" sz="1500" dirty="0">
+                <a:solidFill>
+                  <a:srgbClr val="212121"/>
+                </a:solidFill>
+                <a:latin typeface="Calibri" pitchFamily="34" charset="0"/>
+                <a:ea typeface="Calibri" pitchFamily="34" charset="-122"/>
+                <a:cs typeface="Calibri" pitchFamily="34" charset="-120"/>
+              </a:rPr>
+              <a:t>Runtime context Toolbox model can't express (per-user filtering, session state)</a:t>
+            </a:r>
+            <a:endParaRPr lang="en-US" sz="1500" dirty="0"/>
+          </a:p>
+          <a:p>
+            <a:pPr marL="342900" indent="-342900">
+              <a:spcAft>
+                <a:spcPts val="600"/>
+              </a:spcAft>
+              <a:buSzPct val="100000"/>
+              <a:buChar char="•"/>
+            </a:pPr>
+            <a:r>
+              <a:rPr lang="en-US" sz="1500" dirty="0">
+                <a:solidFill>
+                  <a:srgbClr val="212121"/>
+                </a:solidFill>
+                <a:latin typeface="Calibri" pitchFamily="34" charset="0"/>
+                <a:ea typeface="Calibri" pitchFamily="34" charset="-122"/>
+                <a:cs typeface="Calibri" pitchFamily="34" charset="-120"/>
+              </a:rPr>
+              <a:t>Prototyping fast — don't want to publish a toolbox yet</a:t>
+            </a:r>
+            <a:endParaRPr lang="en-US" sz="1500" dirty="0"/>
+          </a:p>
+          <a:p>
+            <a:pPr marL="342900" indent="-342900">
+              <a:spcAft>
+                <a:spcPts val="600"/>
+              </a:spcAft>
+              <a:buSzPct val="100000"/>
+              <a:buChar char="•"/>
+            </a:pPr>
+            <a:r>
+              <a:rPr lang="en-US" sz="1500" dirty="0">
+                <a:solidFill>
+                  <a:srgbClr val="212121"/>
+                </a:solidFill>
+                <a:latin typeface="Calibri" pitchFamily="34" charset="0"/>
+                <a:ea typeface="Calibri" pitchFamily="34" charset="-122"/>
+                <a:cs typeface="Calibri" pitchFamily="34" charset="-120"/>
+              </a:rPr>
+              <a:t>Tool talks to something inside your app's process (in-memory cache, local model)</a:t>
+            </a:r>
+            <a:endParaRPr lang="en-US" sz="1500" dirty="0"/>
+          </a:p>
+        </p:txBody>
+      </p:sp>
+      <p:sp>
+        <p:nvSpPr>
+          <p:cNvPr id="8" name="Text 6"/>
+          <p:cNvSpPr/>
+          <p:nvPr/>
+        </p:nvSpPr>
+        <p:spPr>
+          <a:xfrm>
+            <a:off x="4709160" y="1554480"/>
+            <a:ext cx="4069080" cy="3291840"/>
+          </a:xfrm>
+          <a:prstGeom prst="rect">
+            <a:avLst/>
+          </a:prstGeom>
+          <a:noFill/>
+          <a:ln/>
+        </p:spPr>
+        <p:txBody>
+          <a:bodyPr wrap="square" rtlCol="0" anchor="ctr"/>
+          <a:lstStyle/>
+          <a:p>
+            <a:pPr marL="342900" indent="-342900">
+              <a:spcAft>
+                <a:spcPts val="600"/>
+              </a:spcAft>
+              <a:buSzPct val="100000"/>
+              <a:buChar char="•"/>
+            </a:pPr>
+            <a:r>
+              <a:rPr lang="en-US" sz="1500" dirty="0">
+                <a:solidFill>
+                  <a:srgbClr val="212121"/>
+                </a:solidFill>
+                <a:latin typeface="Calibri" pitchFamily="34" charset="0"/>
+                <a:ea typeface="Calibri" pitchFamily="34" charset="-122"/>
+                <a:cs typeface="Calibri" pitchFamily="34" charset="-120"/>
+              </a:rPr>
+              <a:t>Tool is a shared capability across agents</a:t>
+            </a:r>
+            <a:endParaRPr lang="en-US" sz="1500" dirty="0"/>
+          </a:p>
+          <a:p>
+            <a:pPr marL="342900" indent="-342900">
+              <a:spcAft>
+                <a:spcPts val="600"/>
+              </a:spcAft>
+              <a:buSzPct val="100000"/>
+              <a:buChar char="•"/>
+            </a:pPr>
+            <a:r>
+              <a:rPr lang="en-US" sz="1500" dirty="0">
+                <a:solidFill>
+                  <a:srgbClr val="212121"/>
+                </a:solidFill>
+                <a:latin typeface="Calibri" pitchFamily="34" charset="0"/>
+                <a:ea typeface="Calibri" pitchFamily="34" charset="-122"/>
+                <a:cs typeface="Calibri" pitchFamily="34" charset="-120"/>
+              </a:rPr>
+              <a:t>Want central governance, RBAC, and audit</a:t>
+            </a:r>
+            <a:endParaRPr lang="en-US" sz="1500" dirty="0"/>
+          </a:p>
+          <a:p>
+            <a:pPr marL="342900" indent="-342900">
+              <a:spcAft>
+                <a:spcPts val="600"/>
+              </a:spcAft>
+              <a:buSzPct val="100000"/>
+              <a:buChar char="•"/>
+            </a:pPr>
+            <a:r>
+              <a:rPr lang="en-US" sz="1500" dirty="0">
+                <a:solidFill>
+                  <a:srgbClr val="212121"/>
+                </a:solidFill>
+                <a:latin typeface="Calibri" pitchFamily="34" charset="0"/>
+                <a:ea typeface="Calibri" pitchFamily="34" charset="-122"/>
+                <a:cs typeface="Calibri" pitchFamily="34" charset="-120"/>
+              </a:rPr>
+              <a:t>Integrates with a supported enterprise system (SharePoint, Fabric, Bing, AI Search, MCP)</a:t>
+            </a:r>
+            <a:endParaRPr lang="en-US" sz="1500" dirty="0"/>
+          </a:p>
+          <a:p>
+            <a:pPr marL="342900" indent="-342900">
+              <a:spcAft>
+                <a:spcPts val="600"/>
+              </a:spcAft>
+              <a:buSzPct val="100000"/>
+              <a:buChar char="•"/>
+            </a:pPr>
+            <a:r>
+              <a:rPr lang="en-US" sz="1500" dirty="0">
+                <a:solidFill>
+                  <a:srgbClr val="212121"/>
+                </a:solidFill>
+                <a:latin typeface="Calibri" pitchFamily="34" charset="0"/>
+                <a:ea typeface="Calibri" pitchFamily="34" charset="-122"/>
+                <a:cs typeface="Calibri" pitchFamily="34" charset="-120"/>
+              </a:rPr>
+              <a:t>Want versioning as a first-class concern</a:t>
+            </a:r>
+            <a:endParaRPr lang="en-US" sz="1500" dirty="0"/>
+          </a:p>
+        </p:txBody>
+      </p:sp>
+      <p:sp>
+        <p:nvSpPr>
+          <p:cNvPr id="9" name="Text 7"/>
+          <p:cNvSpPr/>
+          <p:nvPr/>
+        </p:nvSpPr>
+        <p:spPr>
+          <a:xfrm>
+            <a:off x="365760" y="4434840"/>
             <a:ext cx="8412480" cy="365760"/>
           </a:xfrm>
           <a:prstGeom prst="rect">
@@ -5791,162 +5989,17 @@
               <a:buNone/>
             </a:pPr>
             <a:r>
-              <a:rPr lang="en-US" sz="1400" dirty="0">
-                <a:solidFill>
-                  <a:srgbClr val="212121"/>
-                </a:solidFill>
-                <a:latin typeface="Calibri" pitchFamily="34" charset="0"/>
-                <a:ea typeface="Calibri" pitchFamily="34" charset="-122"/>
-                <a:cs typeface="Calibri" pitchFamily="34" charset="-120"/>
-              </a:rPr>
-              <a:t>Standard workflow you'll use:</a:t>
-            </a:r>
-            <a:endParaRPr lang="en-US" sz="1400" dirty="0"/>
-          </a:p>
-        </p:txBody>
-      </p:sp>
-      <p:sp>
-        <p:nvSpPr>
-          <p:cNvPr id="6" name="Text 4"/>
-          <p:cNvSpPr/>
-          <p:nvPr/>
-        </p:nvSpPr>
-        <p:spPr>
-          <a:xfrm>
-            <a:off x="365760" y="1417320"/>
-            <a:ext cx="8412480" cy="2377440"/>
-          </a:xfrm>
-          <a:prstGeom prst="rect">
-            <a:avLst/>
-          </a:prstGeom>
-          <a:noFill/>
-          <a:ln/>
-        </p:spPr>
-        <p:txBody>
-          <a:bodyPr wrap="square" rtlCol="0" anchor="ctr"/>
-          <a:lstStyle/>
-          <a:p>
-            <a:pPr marL="342900" indent="-342900">
-              <a:spcAft>
-                <a:spcPts val="600"/>
-              </a:spcAft>
-              <a:buSzPct val="100000"/>
-              <a:buChar char="•"/>
-            </a:pPr>
-            <a:r>
-              <a:rPr lang="en-US" sz="1200" dirty="0">
-                <a:solidFill>
-                  <a:srgbClr val="212121"/>
-                </a:solidFill>
-                <a:latin typeface="Calibri" pitchFamily="34" charset="0"/>
-                <a:ea typeface="Calibri" pitchFamily="34" charset="-122"/>
-                <a:cs typeface="Calibri" pitchFamily="34" charset="-120"/>
-              </a:rPr>
-              <a:t>Create v1 → automatically the default → agents consume via the consumer endpoint</a:t>
-            </a:r>
-            <a:endParaRPr lang="en-US" sz="1200" dirty="0"/>
-          </a:p>
-          <a:p>
-            <a:pPr marL="342900" indent="-342900">
-              <a:spcAft>
-                <a:spcPts val="600"/>
-              </a:spcAft>
-              <a:buSzPct val="100000"/>
-              <a:buChar char="•"/>
-            </a:pPr>
-            <a:r>
-              <a:rPr lang="en-US" sz="1200" dirty="0">
-                <a:solidFill>
-                  <a:srgbClr val="212121"/>
-                </a:solidFill>
-                <a:latin typeface="Calibri" pitchFamily="34" charset="0"/>
-                <a:ea typeface="Calibri" pitchFamily="34" charset="-122"/>
-                <a:cs typeface="Calibri" pitchFamily="34" charset="-120"/>
-              </a:rPr>
-              <a:t>Author v2 (add a tool, tighten a description, swap an MCP connection)</a:t>
-            </a:r>
-            <a:endParaRPr lang="en-US" sz="1200" dirty="0"/>
-          </a:p>
-          <a:p>
-            <a:pPr marL="342900" indent="-342900">
-              <a:spcAft>
-                <a:spcPts val="600"/>
-              </a:spcAft>
-              <a:buSzPct val="100000"/>
-              <a:buChar char="•"/>
-            </a:pPr>
-            <a:r>
-              <a:rPr lang="en-US" sz="1200" dirty="0">
-                <a:solidFill>
-                  <a:srgbClr val="212121"/>
-                </a:solidFill>
-                <a:latin typeface="Calibri" pitchFamily="34" charset="0"/>
-                <a:ea typeface="Calibri" pitchFamily="34" charset="-122"/>
-                <a:cs typeface="Calibri" pitchFamily="34" charset="-120"/>
-              </a:rPr>
-              <a:t>Test against the developer endpoint (/versions/2/mcp) before promotion</a:t>
-            </a:r>
-            <a:endParaRPr lang="en-US" sz="1200" dirty="0"/>
-          </a:p>
-          <a:p>
-            <a:pPr marL="342900" indent="-342900">
-              <a:spcAft>
-                <a:spcPts val="600"/>
-              </a:spcAft>
-              <a:buSzPct val="100000"/>
-              <a:buChar char="•"/>
-            </a:pPr>
-            <a:r>
-              <a:rPr lang="en-US" sz="1200" dirty="0">
-                <a:solidFill>
-                  <a:srgbClr val="212121"/>
-                </a:solidFill>
-                <a:latin typeface="Calibri" pitchFamily="34" charset="0"/>
-                <a:ea typeface="Calibri" pitchFamily="34" charset="-122"/>
-                <a:cs typeface="Calibri" pitchFamily="34" charset="-120"/>
-              </a:rPr>
-              <a:t>Promote v2 to default when validated → agents pick it up on their next call, no code change</a:t>
-            </a:r>
-            <a:endParaRPr lang="en-US" sz="1200" dirty="0"/>
-          </a:p>
-        </p:txBody>
-      </p:sp>
-      <p:sp>
-        <p:nvSpPr>
-          <p:cNvPr id="7" name="Text 5"/>
-          <p:cNvSpPr/>
-          <p:nvPr/>
-        </p:nvSpPr>
-        <p:spPr>
-          <a:xfrm>
-            <a:off x="365760" y="4069080"/>
-            <a:ext cx="8412480" cy="457200"/>
-          </a:xfrm>
-          <a:prstGeom prst="rect">
-            <a:avLst/>
-          </a:prstGeom>
-          <a:noFill/>
-          <a:ln/>
-        </p:spPr>
-        <p:txBody>
-          <a:bodyPr wrap="square" rtlCol="0" anchor="ctr"/>
-          <a:lstStyle/>
-          <a:p>
-            <a:pPr indent="0" marL="0">
-              <a:buNone/>
-            </a:pPr>
-            <a:r>
-              <a:rPr lang="en-US" sz="1200" i="1" dirty="0">
-                <a:solidFill>
-                  <a:srgbClr val="6B7280"/>
-                </a:solidFill>
-                <a:latin typeface="Calibri" pitchFamily="34" charset="0"/>
-                <a:ea typeface="Calibri" pitchFamily="34" charset="-122"/>
-                <a:cs typeface="Calibri" pitchFamily="34" charset="-120"/>
-              </a:rPr>
-              <a:t>The promote step is the 'ship' moment. Same discipline as Prompt agent versioning from Day 1.</a:t>
-            </a:r>
-            <a:endParaRPr lang="en-US" sz="1200" dirty="0"/>
+              <a:rPr lang="en-US" sz="1300" b="1" i="1" dirty="0">
+                <a:solidFill>
+                  <a:srgbClr val="1E2761"/>
+                </a:solidFill>
+                <a:latin typeface="Calibri" pitchFamily="34" charset="0"/>
+                <a:ea typeface="Calibri" pitchFamily="34" charset="-122"/>
+                <a:cs typeface="Calibri" pitchFamily="34" charset="-120"/>
+              </a:rPr>
+              <a:t>Mix both. Real agents often have tools=[my_function_tool, my_toolbox].</a:t>
+            </a:r>
+            <a:endParaRPr lang="en-US" sz="1300" dirty="0"/>
           </a:p>
         </p:txBody>
       </p:sp>
@@ -6074,7 +6127,7 @@
                 <a:ea typeface="Calibri" pitchFamily="34" charset="-122"/>
                 <a:cs typeface="Calibri" pitchFamily="34" charset="-120"/>
               </a:rPr>
-              <a:t>When to build a function tool instead</a:t>
+              <a:t>Common traps</a:t>
             </a:r>
             <a:endParaRPr lang="en-US" sz="2800" dirty="0"/>
           </a:p>
@@ -6089,7 +6142,7 @@
         <p:spPr>
           <a:xfrm>
             <a:off x="365760" y="1097280"/>
-            <a:ext cx="4069080" cy="365760"/>
+            <a:ext cx="8412480" cy="3200400"/>
           </a:xfrm>
           <a:prstGeom prst="rect">
             <a:avLst/>
@@ -6098,84 +6151,6 @@
           <a:ln/>
         </p:spPr>
         <p:txBody>
-          <a:bodyPr wrap="square" lIns="0" tIns="0" rIns="0" bIns="0" rtlCol="0" anchor="ctr"/>
-          <a:lstStyle/>
-          <a:p>
-            <a:pPr indent="0" marL="0">
-              <a:buNone/>
-            </a:pPr>
-            <a:r>
-              <a:rPr lang="en-US" sz="2000" b="1" dirty="0">
-                <a:solidFill>
-                  <a:srgbClr val="1E2761"/>
-                </a:solidFill>
-                <a:latin typeface="Calibri" pitchFamily="34" charset="0"/>
-                <a:ea typeface="Calibri" pitchFamily="34" charset="-122"/>
-                <a:cs typeface="Calibri" pitchFamily="34" charset="-120"/>
-              </a:rPr>
-              <a:t>Custom function tool (Module 6)</a:t>
-            </a:r>
-            <a:endParaRPr lang="en-US" sz="2000" dirty="0"/>
-          </a:p>
-        </p:txBody>
-      </p:sp>
-      <p:sp>
-        <p:nvSpPr>
-          <p:cNvPr id="6" name="Text 4"/>
-          <p:cNvSpPr/>
-          <p:nvPr/>
-        </p:nvSpPr>
-        <p:spPr>
-          <a:xfrm>
-            <a:off x="4709160" y="1097280"/>
-            <a:ext cx="4069080" cy="365760"/>
-          </a:xfrm>
-          <a:prstGeom prst="rect">
-            <a:avLst/>
-          </a:prstGeom>
-          <a:noFill/>
-          <a:ln/>
-        </p:spPr>
-        <p:txBody>
-          <a:bodyPr wrap="square" lIns="0" tIns="0" rIns="0" bIns="0" rtlCol="0" anchor="ctr"/>
-          <a:lstStyle/>
-          <a:p>
-            <a:pPr indent="0" marL="0">
-              <a:buNone/>
-            </a:pPr>
-            <a:r>
-              <a:rPr lang="en-US" sz="2000" b="1" dirty="0">
-                <a:solidFill>
-                  <a:srgbClr val="1E2761"/>
-                </a:solidFill>
-                <a:latin typeface="Calibri" pitchFamily="34" charset="0"/>
-                <a:ea typeface="Calibri" pitchFamily="34" charset="-122"/>
-                <a:cs typeface="Calibri" pitchFamily="34" charset="-120"/>
-              </a:rPr>
-              <a:t>Foundry Toolbox</a:t>
-            </a:r>
-            <a:endParaRPr lang="en-US" sz="2000" dirty="0"/>
-          </a:p>
-        </p:txBody>
-      </p:sp>
-      <p:sp>
-        <p:nvSpPr>
-          <p:cNvPr id="7" name="Text 5"/>
-          <p:cNvSpPr/>
-          <p:nvPr/>
-        </p:nvSpPr>
-        <p:spPr>
-          <a:xfrm>
-            <a:off x="365760" y="1554480"/>
-            <a:ext cx="4069080" cy="3291840"/>
-          </a:xfrm>
-          <a:prstGeom prst="rect">
-            <a:avLst/>
-          </a:prstGeom>
-          <a:noFill/>
-          <a:ln/>
-        </p:spPr>
-        <p:txBody>
           <a:bodyPr wrap="square" rtlCol="0" anchor="ctr"/>
           <a:lstStyle/>
           <a:p>
@@ -6187,7 +6162,7 @@
               <a:buChar char="•"/>
             </a:pPr>
             <a:r>
-              <a:rPr lang="en-US" sz="1500" dirty="0">
+              <a:rPr lang="en-US" sz="1200" dirty="0">
                 <a:solidFill>
                   <a:srgbClr val="212121"/>
                 </a:solidFill>
@@ -6195,9 +6170,9 @@
                 <a:ea typeface="Calibri" pitchFamily="34" charset="-122"/>
                 <a:cs typeface="Calibri" pitchFamily="34" charset="-120"/>
               </a:rPr>
-              <a:t>Logic doesn't fit any Toolbox catalog entry</a:t>
-            </a:r>
-            <a:endParaRPr lang="en-US" sz="1500" dirty="0"/>
+              <a:t>Credentials in the YAML — don't. Use connections. YAML is checked into source.</a:t>
+            </a:r>
+            <a:endParaRPr lang="en-US" sz="1200" dirty="0"/>
           </a:p>
           <a:p>
             <a:pPr marL="342900" indent="-342900">
@@ -6208,7 +6183,7 @@
               <a:buChar char="•"/>
             </a:pPr>
             <a:r>
-              <a:rPr lang="en-US" sz="1500" dirty="0">
+              <a:rPr lang="en-US" sz="1200" dirty="0">
                 <a:solidFill>
                   <a:srgbClr val="212121"/>
                 </a:solidFill>
@@ -6216,9 +6191,9 @@
                 <a:ea typeface="Calibri" pitchFamily="34" charset="-122"/>
                 <a:cs typeface="Calibri" pitchFamily="34" charset="-120"/>
               </a:rPr>
-              <a:t>Runtime context Toolbox model can't express (per-user filtering, session state)</a:t>
-            </a:r>
-            <a:endParaRPr lang="en-US" sz="1500" dirty="0"/>
+              <a:t>Consumer vs. developer endpoint confusion — agents = consumer; test = developer.</a:t>
+            </a:r>
+            <a:endParaRPr lang="en-US" sz="1200" dirty="0"/>
           </a:p>
           <a:p>
             <a:pPr marL="342900" indent="-342900">
@@ -6229,7 +6204,7 @@
               <a:buChar char="•"/>
             </a:pPr>
             <a:r>
-              <a:rPr lang="en-US" sz="1500" dirty="0">
+              <a:rPr lang="en-US" sz="1200" dirty="0">
                 <a:solidFill>
                   <a:srgbClr val="212121"/>
                 </a:solidFill>
@@ -6237,9 +6212,9 @@
                 <a:ea typeface="Calibri" pitchFamily="34" charset="-122"/>
                 <a:cs typeface="Calibri" pitchFamily="34" charset="-120"/>
               </a:rPr>
-              <a:t>Prototyping fast — don't want to publish a toolbox yet</a:t>
-            </a:r>
-            <a:endParaRPr lang="en-US" sz="1500" dirty="0"/>
+              <a:t>Not testing before promoting — v2 is default the moment you promote. Test /versions/2/mcp first.</a:t>
+            </a:r>
+            <a:endParaRPr lang="en-US" sz="1200" dirty="0"/>
           </a:p>
           <a:p>
             <a:pPr marL="342900" indent="-342900">
@@ -6250,7 +6225,7 @@
               <a:buChar char="•"/>
             </a:pPr>
             <a:r>
-              <a:rPr lang="en-US" sz="1500" dirty="0">
+              <a:rPr lang="en-US" sz="1200" dirty="0">
                 <a:solidFill>
                   <a:srgbClr val="212121"/>
                 </a:solidFill>
@@ -6258,32 +6233,10 @@
                 <a:ea typeface="Calibri" pitchFamily="34" charset="-122"/>
                 <a:cs typeface="Calibri" pitchFamily="34" charset="-120"/>
               </a:rPr>
-              <a:t>Tool talks to something inside your app's process (in-memory cache, local model)</a:t>
-            </a:r>
-            <a:endParaRPr lang="en-US" sz="1500" dirty="0"/>
-          </a:p>
-        </p:txBody>
-      </p:sp>
-      <p:sp>
-        <p:nvSpPr>
-          <p:cNvPr id="8" name="Text 6"/>
-          <p:cNvSpPr/>
-          <p:nvPr/>
-        </p:nvSpPr>
-        <p:spPr>
-          <a:xfrm>
-            <a:off x="4709160" y="1554480"/>
-            <a:ext cx="4069080" cy="3291840"/>
-          </a:xfrm>
-          <a:prstGeom prst="rect">
-            <a:avLst/>
-          </a:prstGeom>
-          <a:noFill/>
-          <a:ln/>
-        </p:spPr>
-        <p:txBody>
-          <a:bodyPr wrap="square" rtlCol="0" anchor="ctr"/>
-          <a:lstStyle/>
+              <a:t>Too many tools in one toolbox — ≤10 per agent applies. Use toolbox_search when &gt;10.</a:t>
+            </a:r>
+            <a:endParaRPr lang="en-US" sz="1200" dirty="0"/>
+          </a:p>
           <a:p>
             <a:pPr marL="342900" indent="-342900">
               <a:spcAft>
@@ -6293,7 +6246,7 @@
               <a:buChar char="•"/>
             </a:pPr>
             <a:r>
-              <a:rPr lang="en-US" sz="1500" dirty="0">
+              <a:rPr lang="en-US" sz="1200" dirty="0">
                 <a:solidFill>
                   <a:srgbClr val="212121"/>
                 </a:solidFill>
@@ -6301,9 +6254,9 @@
                 <a:ea typeface="Calibri" pitchFamily="34" charset="-122"/>
                 <a:cs typeface="Calibri" pitchFamily="34" charset="-120"/>
               </a:rPr>
-              <a:t>Tool is a shared capability across agents</a:t>
-            </a:r>
-            <a:endParaRPr lang="en-US" sz="1500" dirty="0"/>
+              <a:t>Assuming toolbox tools are free — some have per-call costs (Bing, code interpreter). Budget.</a:t>
+            </a:r>
+            <a:endParaRPr lang="en-US" sz="1200" dirty="0"/>
           </a:p>
           <a:p>
             <a:pPr marL="342900" indent="-342900">
@@ -6314,7 +6267,7 @@
               <a:buChar char="•"/>
             </a:pPr>
             <a:r>
-              <a:rPr lang="en-US" sz="1500" dirty="0">
+              <a:rPr lang="en-US" sz="1200" dirty="0">
                 <a:solidFill>
                   <a:srgbClr val="212121"/>
                 </a:solidFill>
@@ -6322,90 +6275,9 @@
                 <a:ea typeface="Calibri" pitchFamily="34" charset="-122"/>
                 <a:cs typeface="Calibri" pitchFamily="34" charset="-120"/>
               </a:rPr>
-              <a:t>Want central governance, RBAC, and audit</a:t>
-            </a:r>
-            <a:endParaRPr lang="en-US" sz="1500" dirty="0"/>
-          </a:p>
-          <a:p>
-            <a:pPr marL="342900" indent="-342900">
-              <a:spcAft>
-                <a:spcPts val="600"/>
-              </a:spcAft>
-              <a:buSzPct val="100000"/>
-              <a:buChar char="•"/>
-            </a:pPr>
-            <a:r>
-              <a:rPr lang="en-US" sz="1500" dirty="0">
-                <a:solidFill>
-                  <a:srgbClr val="212121"/>
-                </a:solidFill>
-                <a:latin typeface="Calibri" pitchFamily="34" charset="0"/>
-                <a:ea typeface="Calibri" pitchFamily="34" charset="-122"/>
-                <a:cs typeface="Calibri" pitchFamily="34" charset="-120"/>
-              </a:rPr>
-              <a:t>Integrates with a supported enterprise system (SharePoint, Fabric, Bing, AI Search, MCP)</a:t>
-            </a:r>
-            <a:endParaRPr lang="en-US" sz="1500" dirty="0"/>
-          </a:p>
-          <a:p>
-            <a:pPr marL="342900" indent="-342900">
-              <a:spcAft>
-                <a:spcPts val="600"/>
-              </a:spcAft>
-              <a:buSzPct val="100000"/>
-              <a:buChar char="•"/>
-            </a:pPr>
-            <a:r>
-              <a:rPr lang="en-US" sz="1500" dirty="0">
-                <a:solidFill>
-                  <a:srgbClr val="212121"/>
-                </a:solidFill>
-                <a:latin typeface="Calibri" pitchFamily="34" charset="0"/>
-                <a:ea typeface="Calibri" pitchFamily="34" charset="-122"/>
-                <a:cs typeface="Calibri" pitchFamily="34" charset="-120"/>
-              </a:rPr>
-              <a:t>Want versioning as a first-class concern</a:t>
-            </a:r>
-            <a:endParaRPr lang="en-US" sz="1500" dirty="0"/>
-          </a:p>
-        </p:txBody>
-      </p:sp>
-      <p:sp>
-        <p:nvSpPr>
-          <p:cNvPr id="9" name="Text 7"/>
-          <p:cNvSpPr/>
-          <p:nvPr/>
-        </p:nvSpPr>
-        <p:spPr>
-          <a:xfrm>
-            <a:off x="365760" y="4434840"/>
-            <a:ext cx="8412480" cy="365760"/>
-          </a:xfrm>
-          <a:prstGeom prst="rect">
-            <a:avLst/>
-          </a:prstGeom>
-          <a:noFill/>
-          <a:ln/>
-        </p:spPr>
-        <p:txBody>
-          <a:bodyPr wrap="square" rtlCol="0" anchor="ctr"/>
-          <a:lstStyle/>
-          <a:p>
-            <a:pPr indent="0" marL="0">
-              <a:buNone/>
-            </a:pPr>
-            <a:r>
-              <a:rPr lang="en-US" sz="1300" b="1" i="1" dirty="0">
-                <a:solidFill>
-                  <a:srgbClr val="1E2761"/>
-                </a:solidFill>
-                <a:latin typeface="Calibri" pitchFamily="34" charset="0"/>
-                <a:ea typeface="Calibri" pitchFamily="34" charset="-122"/>
-                <a:cs typeface="Calibri" pitchFamily="34" charset="-120"/>
-              </a:rPr>
-              <a:t>Mix both. Real agents often have tools=[my_function_tool, my_toolbox].</a:t>
-            </a:r>
-            <a:endParaRPr lang="en-US" sz="1300" dirty="0"/>
+              <a:t>Skipping RAI policy — toolbox is the right place to enforce content safety centrally. Use it.</a:t>
+            </a:r>
+            <a:endParaRPr lang="en-US" sz="1200" dirty="0"/>
           </a:p>
         </p:txBody>
       </p:sp>
@@ -6420,284 +6292,6 @@
 <file path=ppt/slides/slide18.xml><?xml version="1.0" encoding="utf-8"?>
 <p:sld xmlns:a="http://schemas.openxmlformats.org/drawingml/2006/main" xmlns:r="http://schemas.openxmlformats.org/officeDocument/2006/relationships" xmlns:p="http://schemas.openxmlformats.org/presentationml/2006/main">
   <p:cSld name="Slide 18">
-    <p:bg>
-      <p:bgPr>
-        <a:solidFill>
-          <a:srgbClr val="FFFFFF"/>
-        </a:solidFill>
-      </p:bgPr>
-    </p:bg>
-    <p:spTree>
-      <p:nvGrpSpPr>
-        <p:cNvPr id="1" name=""/>
-        <p:cNvGrpSpPr/>
-        <p:nvPr/>
-      </p:nvGrpSpPr>
-      <p:grpSpPr>
-        <a:xfrm>
-          <a:off x="0" y="0"/>
-          <a:ext cx="0" cy="0"/>
-          <a:chOff x="0" y="0"/>
-          <a:chExt cx="0" cy="0"/>
-        </a:xfrm>
-      </p:grpSpPr>
-      <p:sp>
-        <p:nvSpPr>
-          <p:cNvPr id="2" name="Shape 0"/>
-          <p:cNvSpPr/>
-          <p:nvPr/>
-        </p:nvSpPr>
-        <p:spPr>
-          <a:xfrm>
-            <a:off x="0" y="0"/>
-            <a:ext cx="54864" cy="5143500"/>
-          </a:xfrm>
-          <a:prstGeom prst="rect">
-            <a:avLst/>
-          </a:prstGeom>
-          <a:solidFill>
-            <a:srgbClr val="1E2761"/>
-          </a:solidFill>
-          <a:ln/>
-        </p:spPr>
-      </p:sp>
-      <p:sp>
-        <p:nvSpPr>
-          <p:cNvPr id="3" name="Text 1"/>
-          <p:cNvSpPr/>
-          <p:nvPr/>
-        </p:nvSpPr>
-        <p:spPr>
-          <a:xfrm>
-            <a:off x="5669280" y="274320"/>
-            <a:ext cx="3291840" cy="274320"/>
-          </a:xfrm>
-          <a:prstGeom prst="rect">
-            <a:avLst/>
-          </a:prstGeom>
-          <a:noFill/>
-          <a:ln/>
-        </p:spPr>
-        <p:txBody>
-          <a:bodyPr wrap="square" lIns="0" tIns="0" rIns="0" bIns="0" rtlCol="0" anchor="ctr"/>
-          <a:lstStyle/>
-          <a:p>
-            <a:pPr algn="r" indent="0" marL="0">
-              <a:buNone/>
-            </a:pPr>
-            <a:r>
-              <a:rPr lang="en-US" sz="1000" dirty="0">
-                <a:solidFill>
-                  <a:srgbClr val="6B7280"/>
-                </a:solidFill>
-                <a:latin typeface="Calibri" pitchFamily="34" charset="0"/>
-                <a:ea typeface="Calibri" pitchFamily="34" charset="-122"/>
-                <a:cs typeface="Calibri" pitchFamily="34" charset="-120"/>
-              </a:rPr>
-              <a:t>Day 2 · Module 5</a:t>
-            </a:r>
-            <a:endParaRPr lang="en-US" sz="1000" dirty="0"/>
-          </a:p>
-        </p:txBody>
-      </p:sp>
-      <p:sp>
-        <p:nvSpPr>
-          <p:cNvPr id="4" name="Text 2"/>
-          <p:cNvSpPr/>
-          <p:nvPr/>
-        </p:nvSpPr>
-        <p:spPr>
-          <a:xfrm>
-            <a:off x="365760" y="320040"/>
-            <a:ext cx="6217920" cy="640080"/>
-          </a:xfrm>
-          <a:prstGeom prst="rect">
-            <a:avLst/>
-          </a:prstGeom>
-          <a:noFill/>
-          <a:ln/>
-        </p:spPr>
-        <p:txBody>
-          <a:bodyPr wrap="square" lIns="0" tIns="0" rIns="0" bIns="0" rtlCol="0" anchor="ctr"/>
-          <a:lstStyle/>
-          <a:p>
-            <a:pPr indent="0" marL="0">
-              <a:buNone/>
-            </a:pPr>
-            <a:r>
-              <a:rPr lang="en-US" sz="2800" b="1" dirty="0">
-                <a:solidFill>
-                  <a:srgbClr val="1E2761"/>
-                </a:solidFill>
-                <a:latin typeface="Calibri" pitchFamily="34" charset="0"/>
-                <a:ea typeface="Calibri" pitchFamily="34" charset="-122"/>
-                <a:cs typeface="Calibri" pitchFamily="34" charset="-120"/>
-              </a:rPr>
-              <a:t>Common traps</a:t>
-            </a:r>
-            <a:endParaRPr lang="en-US" sz="2800" dirty="0"/>
-          </a:p>
-        </p:txBody>
-      </p:sp>
-      <p:sp>
-        <p:nvSpPr>
-          <p:cNvPr id="5" name="Text 3"/>
-          <p:cNvSpPr/>
-          <p:nvPr/>
-        </p:nvSpPr>
-        <p:spPr>
-          <a:xfrm>
-            <a:off x="365760" y="1097280"/>
-            <a:ext cx="8412480" cy="3200400"/>
-          </a:xfrm>
-          <a:prstGeom prst="rect">
-            <a:avLst/>
-          </a:prstGeom>
-          <a:noFill/>
-          <a:ln/>
-        </p:spPr>
-        <p:txBody>
-          <a:bodyPr wrap="square" rtlCol="0" anchor="ctr"/>
-          <a:lstStyle/>
-          <a:p>
-            <a:pPr marL="342900" indent="-342900">
-              <a:spcAft>
-                <a:spcPts val="600"/>
-              </a:spcAft>
-              <a:buSzPct val="100000"/>
-              <a:buChar char="•"/>
-            </a:pPr>
-            <a:r>
-              <a:rPr lang="en-US" sz="1200" dirty="0">
-                <a:solidFill>
-                  <a:srgbClr val="212121"/>
-                </a:solidFill>
-                <a:latin typeface="Calibri" pitchFamily="34" charset="0"/>
-                <a:ea typeface="Calibri" pitchFamily="34" charset="-122"/>
-                <a:cs typeface="Calibri" pitchFamily="34" charset="-120"/>
-              </a:rPr>
-              <a:t>Credentials in the YAML — don't. Use connections. YAML is checked into source.</a:t>
-            </a:r>
-            <a:endParaRPr lang="en-US" sz="1200" dirty="0"/>
-          </a:p>
-          <a:p>
-            <a:pPr marL="342900" indent="-342900">
-              <a:spcAft>
-                <a:spcPts val="600"/>
-              </a:spcAft>
-              <a:buSzPct val="100000"/>
-              <a:buChar char="•"/>
-            </a:pPr>
-            <a:r>
-              <a:rPr lang="en-US" sz="1200" dirty="0">
-                <a:solidFill>
-                  <a:srgbClr val="212121"/>
-                </a:solidFill>
-                <a:latin typeface="Calibri" pitchFamily="34" charset="0"/>
-                <a:ea typeface="Calibri" pitchFamily="34" charset="-122"/>
-                <a:cs typeface="Calibri" pitchFamily="34" charset="-120"/>
-              </a:rPr>
-              <a:t>Consumer vs. developer endpoint confusion — agents = consumer; test = developer.</a:t>
-            </a:r>
-            <a:endParaRPr lang="en-US" sz="1200" dirty="0"/>
-          </a:p>
-          <a:p>
-            <a:pPr marL="342900" indent="-342900">
-              <a:spcAft>
-                <a:spcPts val="600"/>
-              </a:spcAft>
-              <a:buSzPct val="100000"/>
-              <a:buChar char="•"/>
-            </a:pPr>
-            <a:r>
-              <a:rPr lang="en-US" sz="1200" dirty="0">
-                <a:solidFill>
-                  <a:srgbClr val="212121"/>
-                </a:solidFill>
-                <a:latin typeface="Calibri" pitchFamily="34" charset="0"/>
-                <a:ea typeface="Calibri" pitchFamily="34" charset="-122"/>
-                <a:cs typeface="Calibri" pitchFamily="34" charset="-120"/>
-              </a:rPr>
-              <a:t>Not testing before promoting — v2 is default the moment you promote. Test /versions/2/mcp first.</a:t>
-            </a:r>
-            <a:endParaRPr lang="en-US" sz="1200" dirty="0"/>
-          </a:p>
-          <a:p>
-            <a:pPr marL="342900" indent="-342900">
-              <a:spcAft>
-                <a:spcPts val="600"/>
-              </a:spcAft>
-              <a:buSzPct val="100000"/>
-              <a:buChar char="•"/>
-            </a:pPr>
-            <a:r>
-              <a:rPr lang="en-US" sz="1200" dirty="0">
-                <a:solidFill>
-                  <a:srgbClr val="212121"/>
-                </a:solidFill>
-                <a:latin typeface="Calibri" pitchFamily="34" charset="0"/>
-                <a:ea typeface="Calibri" pitchFamily="34" charset="-122"/>
-                <a:cs typeface="Calibri" pitchFamily="34" charset="-120"/>
-              </a:rPr>
-              <a:t>Too many tools in one toolbox — ≤10 per agent applies. Use toolbox_search when &gt;10.</a:t>
-            </a:r>
-            <a:endParaRPr lang="en-US" sz="1200" dirty="0"/>
-          </a:p>
-          <a:p>
-            <a:pPr marL="342900" indent="-342900">
-              <a:spcAft>
-                <a:spcPts val="600"/>
-              </a:spcAft>
-              <a:buSzPct val="100000"/>
-              <a:buChar char="•"/>
-            </a:pPr>
-            <a:r>
-              <a:rPr lang="en-US" sz="1200" dirty="0">
-                <a:solidFill>
-                  <a:srgbClr val="212121"/>
-                </a:solidFill>
-                <a:latin typeface="Calibri" pitchFamily="34" charset="0"/>
-                <a:ea typeface="Calibri" pitchFamily="34" charset="-122"/>
-                <a:cs typeface="Calibri" pitchFamily="34" charset="-120"/>
-              </a:rPr>
-              <a:t>Assuming toolbox tools are free — some have per-call costs (Bing, code interpreter). Budget.</a:t>
-            </a:r>
-            <a:endParaRPr lang="en-US" sz="1200" dirty="0"/>
-          </a:p>
-          <a:p>
-            <a:pPr marL="342900" indent="-342900">
-              <a:spcAft>
-                <a:spcPts val="600"/>
-              </a:spcAft>
-              <a:buSzPct val="100000"/>
-              <a:buChar char="•"/>
-            </a:pPr>
-            <a:r>
-              <a:rPr lang="en-US" sz="1200" dirty="0">
-                <a:solidFill>
-                  <a:srgbClr val="212121"/>
-                </a:solidFill>
-                <a:latin typeface="Calibri" pitchFamily="34" charset="0"/>
-                <a:ea typeface="Calibri" pitchFamily="34" charset="-122"/>
-                <a:cs typeface="Calibri" pitchFamily="34" charset="-120"/>
-              </a:rPr>
-              <a:t>Skipping RAI policy — toolbox is the right place to enforce content safety centrally. Use it.</a:t>
-            </a:r>
-            <a:endParaRPr lang="en-US" sz="1200" dirty="0"/>
-          </a:p>
-        </p:txBody>
-      </p:sp>
-    </p:spTree>
-  </p:cSld>
-  <p:clrMapOvr>
-    <a:masterClrMapping/>
-  </p:clrMapOvr>
-</p:sld>
-</file>
-
-<file path=ppt/slides/slide19.xml><?xml version="1.0" encoding="utf-8"?>
-<p:sld xmlns:a="http://schemas.openxmlformats.org/drawingml/2006/main" xmlns:r="http://schemas.openxmlformats.org/officeDocument/2006/relationships" xmlns:p="http://schemas.openxmlformats.org/presentationml/2006/main">
-  <p:cSld name="Slide 19">
     <p:bg>
       <p:bgPr>
         <a:solidFill>

</xml_diff>